<commit_message>
deck(pptx): fix slide-6 honest-ceiling note overflowing right margin
</commit_message>
<xml_diff>
--- a/CryoClear.pptx
+++ b/CryoClear.pptx
@@ -9923,8 +9923,8 @@
         </p:nvSpPr>
         <p:spPr>
           <a:xfrm>
-            <a:off x="8586216" y="2331720"/>
-            <a:ext cx="3703320" cy="3035808"/>
+            <a:off x="8494776" y="2331720"/>
+            <a:ext cx="3008376" cy="3035808"/>
           </a:xfrm>
           <a:prstGeom prst="roundRect">
             <a:avLst>
@@ -9969,7 +9969,7 @@
         </p:nvSpPr>
         <p:spPr>
           <a:xfrm>
-            <a:off x="8586216" y="2331720"/>
+            <a:off x="8494776" y="2331720"/>
             <a:ext cx="54864" cy="3035808"/>
           </a:xfrm>
           <a:prstGeom prst="rect">
@@ -10013,8 +10013,8 @@
         </p:nvSpPr>
         <p:spPr>
           <a:xfrm>
-            <a:off x="8860536" y="2478024"/>
-            <a:ext cx="3246120" cy="2761488"/>
+            <a:off x="8769096" y="2478024"/>
+            <a:ext cx="2551176" cy="2761488"/>
           </a:xfrm>
           <a:prstGeom prst="rect">
             <a:avLst/>

</xml_diff>